<commit_message>
Update pitch deck: Track 1, full name, add freshness SLA, remove Azure
- Track 1, Damini Thandele, Date: 10 Oct 2026
- Remove CSV from Feature Store references
- Add freshness SLA to architecture and monitoring sections
- Replace Azure next step with multi-supplier handling
- Fix duplicate bullet in next steps

Co-Authored-By: Claude Opus 4.6 <noreply@anthropic.com>
</commit_message>
<xml_diff>
--- a/PITCH_DECK.pptx
+++ b/PITCH_DECK.pptx
@@ -1732,7 +1732,7 @@
                   <a:srgbClr val="FFFFFF"/>
                 </a:solidFill>
               </a:rPr>
-              <a:t>Track 2</a:t>
+              <a:t>Track 1</a:t>
             </a:r>
             <a:endParaRPr lang="en-US" sz="1400" dirty="0"/>
           </a:p>
@@ -1882,7 +1882,7 @@
                   <a:srgbClr val="FFFFFF"/>
                 </a:solidFill>
               </a:rPr>
-              <a:t>Damie</a:t>
+              <a:t>Damini Thandele</a:t>
             </a:r>
             <a:endParaRPr lang="en-US" sz="1400" dirty="0"/>
           </a:p>
@@ -1918,7 +1918,7 @@
                   <a:srgbClr val="F3E7DF"/>
                 </a:solidFill>
               </a:rPr>
-              <a:t>Presented by: Damie   ·   Date: 29 Sep 2026</a:t>
+              <a:t>Presented by: Damini Thandele   ·   Date: 10 Oct 2026</a:t>
             </a:r>
             <a:endParaRPr lang="en-US" sz="1200" dirty="0"/>
           </a:p>
@@ -3072,8 +3072,7 @@
                   <a:srgbClr val="FFFFFF"/>
                 </a:solidFill>
               </a:rPr>
-              <a:t>Feature Store
-(CSV)</a:t>
+              <a:t>Feature Store</a:t>
             </a:r>
             <a:endParaRPr lang="en-US" sz="1200" dirty="0"/>
           </a:p>
@@ -3313,7 +3312,7 @@
                   <a:srgbClr val="9B958F"/>
                 </a:solidFill>
               </a:rPr>
-              <a:t>Data flows left → right: 58 supplier notes are processed by GPT-4o into structured signals, merged with 15 ERP features in a CSV feature store, then fed to XGBoost for next-day sales prediction.</a:t>
+              <a:t>Data flows left → right: 58 supplier notes are processed by GPT-4o into structured signals, merged with 15 ERP features in a feature store with freshness SLA, then fed to XGBoost for next-day sales prediction.</a:t>
             </a:r>
             <a:endParaRPr lang="en-US" sz="1050" dirty="0"/>
           </a:p>
@@ -3435,7 +3434,7 @@
                 </a:solidFill>
                 <a:latin typeface="Calibri"/>
               </a:rPr>
-              <a:t>•  Feature Store — 18 features in CSV with lineage metadata and 24h freshness SLA</a:t>
+              <a:t>•  Feature Store — 18 features with lineage metadata and 24h freshness SLA</a:t>
             </a:r>
           </a:p>
           <a:p>
@@ -3589,7 +3588,7 @@
                 </a:solidFill>
                 <a:latin typeface="Calibri"/>
               </a:rPr>
-              <a:t>•  Data Engineering — Feature store design with CSV storage and lineage tracking</a:t>
+              <a:t>•  Data Engineering — Feature store design with lineage tracking and freshness SLA</a:t>
             </a:r>
           </a:p>
           <a:p>
@@ -4084,7 +4083,7 @@
                 </a:solidFill>
                 <a:latin typeface="Calibri"/>
               </a:rPr>
-              <a:t>•  Step 3: Build feature store — 18 features saved to CSV with lineage metadata</a:t>
+              <a:t>•  Step 3: Build feature store — 18 features with lineage metadata and freshness SLA</a:t>
             </a:r>
           </a:p>
           <a:p>
@@ -5090,7 +5089,7 @@
                 </a:solidFill>
                 <a:latin typeface="Calibri"/>
               </a:rPr>
-              <a:t>    Feature Store — CSV storage with lineage metadata for full traceability</a:t>
+              <a:t>    Feature Store — Lineage metadata and 24h freshness SLA for full traceability</a:t>
             </a:r>
           </a:p>
         </p:txBody>
@@ -5735,7 +5734,7 @@
                 </a:solidFill>
                 <a:latin typeface="Calibri"/>
               </a:rPr>
-              <a:t>•  Azure deployment — Blob Storage for features, Azure ML for inference</a:t>
+              <a:t>•  Real-time extraction — streaming LLM as notes arrive</a:t>
             </a:r>
           </a:p>
           <a:p>
@@ -5746,7 +5745,7 @@
                 </a:solidFill>
                 <a:latin typeface="Calibri"/>
               </a:rPr>
-              <a:t>•  Real-time extraction — streaming LLM as notes arrive</a:t>
+              <a:t>•  Automated retraining triggered by PSI drift alerts</a:t>
             </a:r>
           </a:p>
           <a:p>
@@ -5757,7 +5756,7 @@
                 </a:solidFill>
                 <a:latin typeface="Calibri"/>
               </a:rPr>
-              <a:t>•  Automated retraining triggered by PSI drift alerts</a:t>
+              <a:t>•  Multi-supplier overlap handling for SKUs with multiple sources</a:t>
             </a:r>
           </a:p>
         </p:txBody>

</xml_diff>

<commit_message>
Add LLM extraction evaluation metrics across all deliverables
- Notebook: new Section 2b computes Precision, Recall, F1, Accuracy
  for early_delay_flag and MAE for expected_delay_days vs actual
- Evaluation report (md + docx): new Section 3 with extraction metrics
- Pitch deck: extraction F1 added to slide 5 evaluation method
- One-pager: extraction F1 added to eval line
- Recording script: added spoken line for extraction quality metrics

Co-Authored-By: Claude Opus 4.6 <noreply@anthropic.com>
</commit_message>
<xml_diff>
--- a/PITCH_DECK.pptx
+++ b/PITCH_DECK.pptx
@@ -4916,6 +4916,17 @@
                 </a:solidFill>
                 <a:latin typeface="Calibri"/>
               </a:rPr>
+              <a:t>    LLM Extraction — Precision 100%, Recall 100%, F1 100% on 58 notes</a:t>
+            </a:r>
+          </a:p>
+          <a:p>
+            <a:r>
+              <a:rPr sz="1200" b="0">
+                <a:solidFill>
+                  <a:srgbClr val="1C1C1C"/>
+                </a:solidFill>
+                <a:latin typeface="Calibri"/>
+              </a:rPr>
               <a:t>    Chronological Split — 80% train / 20% test by date (no random shuffle)</a:t>
             </a:r>
           </a:p>
@@ -4939,17 +4950,6 @@
                 <a:latin typeface="Calibri"/>
               </a:rPr>
               <a:t>    Feature Importance — early_delay_flag is the #1 feature in the enhanced model</a:t>
-            </a:r>
-          </a:p>
-          <a:p>
-            <a:r>
-              <a:rPr sz="1200" b="0">
-                <a:solidFill>
-                  <a:srgbClr val="1C1C1C"/>
-                </a:solidFill>
-                <a:latin typeface="Calibri"/>
-              </a:rPr>
-              <a:t>    Synthetic Data — 540 days, 5 SKUs, 4 suppliers with 35–55% reliability</a:t>
             </a:r>
           </a:p>
         </p:txBody>

</xml_diff>